<commit_message>
GIW talk: use official conference name BIOINFO/GIW ISCB-Asia 2026
</commit_message>
<xml_diff>
--- a/pipeline/hspc-velocity-benchmark/manuscript/conf_giw2026/talk/GIW2026_oral241_velocity_reliability_map.pptx
+++ b/pipeline/hspc-velocity-benchmark/manuscript/conf_giw2026/talk/GIW2026_oral241_velocity_reliability_map.pptx
@@ -567,7 +567,7 @@
           </a:p>
           <a:p>
             <a:r>
-              <a:t>Talk based on the GIW/ISCB-Asia 2026 long abstract, submission 241.</a:t>
+              <a:t>Talk based on the BIOINFO/GIW ISCB-Asia 2026 long abstract, submission 241.</a:t>
             </a:r>
           </a:p>
           <a:p/>
@@ -5752,7 +5752,7 @@
                 <a:ea typeface="Pretendard"/>
                 <a:cs typeface="Pretendard"/>
               </a:rPr>
-              <a:t>GIW/ISCB-Asia 2026  ·  Oral presentation, submission 241</a:t>
+              <a:t>BIOINFO/GIW ISCB-Asia 2026  ·  Oral presentation, submission 241</a:t>
             </a:r>
           </a:p>
         </p:txBody>

</xml_diff>